<commit_message>
feat: expand executive slide deck to 9 slides with 3-way reconciliation audit
</commit_message>
<xml_diff>
--- a/EIA_Q4_Executive_Performance_Presentation.pptx
+++ b/EIA_Q4_Executive_Performance_Presentation.pptx
@@ -13,6 +13,7 @@
     <p:sldId id="261" r:id="rId12"/>
     <p:sldId id="262" r:id="rId13"/>
     <p:sldId id="263" r:id="rId14"/>
+    <p:sldId id="264" r:id="rId15"/>
   </p:sldIdLst>
   <p:sldSz cx="12191695" cy="6858000" type="screen4x3"/>
   <p:notesSz cx="6858000" cy="9144000"/>
@@ -4319,6 +4320,1571 @@
               </a:defRPr>
             </a:pPr>
             <a:r>
+              <a:t>DATA INTEGRITY &amp; 3-WAY AUDIT  |  การตรวจสอบความถูกต้องของข้อมูล 3 ฝ่าย ยืนยันความสอดคล้องตรงกัน 100%</a:t>
+            </a:r>
+          </a:p>
+          <a:p>
+            <a:pPr>
+              <a:defRPr sz="1100">
+                <a:solidFill>
+                  <a:srgbClr val="64748B"/>
+                </a:solidFill>
+                <a:latin typeface="Segoe UI"/>
+              </a:defRPr>
+            </a:pPr>
+            <a:r>
+              <a:t>เปรียบเทียบข้อมูลระหว่างไฟล์ Excel ใน OneDrive Q4, แดชบอร์ดส่วนบน และตาราง BU Matrix ด้านล่าง</a:t>
+            </a:r>
+          </a:p>
+        </p:txBody>
+      </p:sp>
+      <p:sp>
+        <p:nvSpPr>
+          <p:cNvPr id="4" name="Rounded Rectangle 3"/>
+          <p:cNvSpPr/>
+          <p:nvPr/>
+        </p:nvSpPr>
+        <p:spPr>
+          <a:xfrm>
+            <a:off x="731520" y="1508760"/>
+            <a:ext cx="3383280" cy="1371600"/>
+          </a:xfrm>
+          <a:prstGeom prst="roundRect">
+            <a:avLst/>
+          </a:prstGeom>
+          <a:solidFill>
+            <a:srgbClr val="FFFFFF"/>
+          </a:solidFill>
+          <a:ln w="12700">
+            <a:solidFill>
+              <a:srgbClr val="E2E8F0"/>
+            </a:solidFill>
+          </a:ln>
+        </p:spPr>
+        <p:style>
+          <a:lnRef idx="1">
+            <a:schemeClr val="accent1"/>
+          </a:lnRef>
+          <a:fillRef idx="3">
+            <a:schemeClr val="accent1"/>
+          </a:fillRef>
+          <a:effectRef idx="2">
+            <a:schemeClr val="accent1"/>
+          </a:effectRef>
+          <a:fontRef idx="minor">
+            <a:schemeClr val="lt1"/>
+          </a:fontRef>
+        </p:style>
+        <p:txBody>
+          <a:bodyPr rtlCol="0" anchor="ctr"/>
+          <a:lstStyle/>
+          <a:p>
+            <a:pPr algn="ctr"/>
+          </a:p>
+        </p:txBody>
+      </p:sp>
+      <p:sp>
+        <p:nvSpPr>
+          <p:cNvPr id="5" name="Rectangle 4"/>
+          <p:cNvSpPr/>
+          <p:nvPr/>
+        </p:nvSpPr>
+        <p:spPr>
+          <a:xfrm>
+            <a:off x="731520" y="1508760"/>
+            <a:ext cx="3383280" cy="73152"/>
+          </a:xfrm>
+          <a:prstGeom prst="rect">
+            <a:avLst/>
+          </a:prstGeom>
+          <a:solidFill>
+            <a:srgbClr val="2563EB"/>
+          </a:solidFill>
+          <a:ln>
+            <a:noFill/>
+          </a:ln>
+        </p:spPr>
+        <p:style>
+          <a:lnRef idx="1">
+            <a:schemeClr val="accent1"/>
+          </a:lnRef>
+          <a:fillRef idx="3">
+            <a:schemeClr val="accent1"/>
+          </a:fillRef>
+          <a:effectRef idx="2">
+            <a:schemeClr val="accent1"/>
+          </a:effectRef>
+          <a:fontRef idx="minor">
+            <a:schemeClr val="lt1"/>
+          </a:fontRef>
+        </p:style>
+        <p:txBody>
+          <a:bodyPr rtlCol="0" anchor="ctr"/>
+          <a:lstStyle/>
+          <a:p>
+            <a:pPr algn="ctr"/>
+          </a:p>
+        </p:txBody>
+      </p:sp>
+      <p:sp>
+        <p:nvSpPr>
+          <p:cNvPr id="6" name="TextBox 5"/>
+          <p:cNvSpPr txBox="1"/>
+          <p:nvPr/>
+        </p:nvSpPr>
+        <p:spPr>
+          <a:xfrm>
+            <a:off x="914400" y="1673352"/>
+            <a:ext cx="3017520" cy="1115568"/>
+          </a:xfrm>
+          <a:prstGeom prst="rect">
+            <a:avLst/>
+          </a:prstGeom>
+          <a:noFill/>
+        </p:spPr>
+        <p:txBody>
+          <a:bodyPr wrap="square" lIns="0" tIns="0" rIns="0" bIns="0">
+            <a:spAutoFit/>
+          </a:bodyPr>
+          <a:lstStyle/>
+          <a:p>
+            <a:pPr>
+              <a:defRPr sz="2800" b="1">
+                <a:solidFill>
+                  <a:srgbClr val="2563EB"/>
+                </a:solidFill>
+                <a:latin typeface="Segoe UI"/>
+              </a:defRPr>
+            </a:pPr>
+            <a:r>
+              <a:t>5,092</a:t>
+            </a:r>
+          </a:p>
+          <a:p>
+            <a:pPr>
+              <a:defRPr sz="1000" b="1">
+                <a:solidFill>
+                  <a:srgbClr val="0F172A"/>
+                </a:solidFill>
+                <a:latin typeface="Segoe UI"/>
+              </a:defRPr>
+            </a:pPr>
+            <a:r>
+              <a:t>Full Baseline Scope</a:t>
+            </a:r>
+          </a:p>
+          <a:p>
+            <a:pPr>
+              <a:defRPr sz="900">
+                <a:solidFill>
+                  <a:srgbClr val="64748B"/>
+                </a:solidFill>
+                <a:latin typeface="Segoe UI"/>
+              </a:defRPr>
+            </a:pPr>
+            <a:r>
+              <a:t>Excel = Dashboard = BU Matrix</a:t>
+            </a:r>
+          </a:p>
+        </p:txBody>
+      </p:sp>
+      <p:sp>
+        <p:nvSpPr>
+          <p:cNvPr id="7" name="Rounded Rectangle 6"/>
+          <p:cNvSpPr/>
+          <p:nvPr/>
+        </p:nvSpPr>
+        <p:spPr>
+          <a:xfrm>
+            <a:off x="4389120" y="1508760"/>
+            <a:ext cx="3383280" cy="1371600"/>
+          </a:xfrm>
+          <a:prstGeom prst="roundRect">
+            <a:avLst/>
+          </a:prstGeom>
+          <a:solidFill>
+            <a:srgbClr val="FFFFFF"/>
+          </a:solidFill>
+          <a:ln w="12700">
+            <a:solidFill>
+              <a:srgbClr val="E2E8F0"/>
+            </a:solidFill>
+          </a:ln>
+        </p:spPr>
+        <p:style>
+          <a:lnRef idx="1">
+            <a:schemeClr val="accent1"/>
+          </a:lnRef>
+          <a:fillRef idx="3">
+            <a:schemeClr val="accent1"/>
+          </a:fillRef>
+          <a:effectRef idx="2">
+            <a:schemeClr val="accent1"/>
+          </a:effectRef>
+          <a:fontRef idx="minor">
+            <a:schemeClr val="lt1"/>
+          </a:fontRef>
+        </p:style>
+        <p:txBody>
+          <a:bodyPr rtlCol="0" anchor="ctr"/>
+          <a:lstStyle/>
+          <a:p>
+            <a:pPr algn="ctr"/>
+          </a:p>
+        </p:txBody>
+      </p:sp>
+      <p:sp>
+        <p:nvSpPr>
+          <p:cNvPr id="8" name="Rectangle 7"/>
+          <p:cNvSpPr/>
+          <p:nvPr/>
+        </p:nvSpPr>
+        <p:spPr>
+          <a:xfrm>
+            <a:off x="4389120" y="1508760"/>
+            <a:ext cx="3383280" cy="73152"/>
+          </a:xfrm>
+          <a:prstGeom prst="rect">
+            <a:avLst/>
+          </a:prstGeom>
+          <a:solidFill>
+            <a:srgbClr val="10B981"/>
+          </a:solidFill>
+          <a:ln>
+            <a:noFill/>
+          </a:ln>
+        </p:spPr>
+        <p:style>
+          <a:lnRef idx="1">
+            <a:schemeClr val="accent1"/>
+          </a:lnRef>
+          <a:fillRef idx="3">
+            <a:schemeClr val="accent1"/>
+          </a:fillRef>
+          <a:effectRef idx="2">
+            <a:schemeClr val="accent1"/>
+          </a:effectRef>
+          <a:fontRef idx="minor">
+            <a:schemeClr val="lt1"/>
+          </a:fontRef>
+        </p:style>
+        <p:txBody>
+          <a:bodyPr rtlCol="0" anchor="ctr"/>
+          <a:lstStyle/>
+          <a:p>
+            <a:pPr algn="ctr"/>
+          </a:p>
+        </p:txBody>
+      </p:sp>
+      <p:sp>
+        <p:nvSpPr>
+          <p:cNvPr id="9" name="TextBox 8"/>
+          <p:cNvSpPr txBox="1"/>
+          <p:nvPr/>
+        </p:nvSpPr>
+        <p:spPr>
+          <a:xfrm>
+            <a:off x="4572000" y="1673352"/>
+            <a:ext cx="3017520" cy="1115568"/>
+          </a:xfrm>
+          <a:prstGeom prst="rect">
+            <a:avLst/>
+          </a:prstGeom>
+          <a:noFill/>
+        </p:spPr>
+        <p:txBody>
+          <a:bodyPr wrap="square" lIns="0" tIns="0" rIns="0" bIns="0">
+            <a:spAutoFit/>
+          </a:bodyPr>
+          <a:lstStyle/>
+          <a:p>
+            <a:pPr>
+              <a:defRPr sz="2800" b="1">
+                <a:solidFill>
+                  <a:srgbClr val="10B981"/>
+                </a:solidFill>
+                <a:latin typeface="Segoe UI"/>
+              </a:defRPr>
+            </a:pPr>
+            <a:r>
+              <a:t>361 (7.09%)</a:t>
+            </a:r>
+          </a:p>
+          <a:p>
+            <a:pPr>
+              <a:defRPr sz="1000" b="1">
+                <a:solidFill>
+                  <a:srgbClr val="0F172A"/>
+                </a:solidFill>
+                <a:latin typeface="Segoe UI"/>
+              </a:defRPr>
+            </a:pPr>
+            <a:r>
+              <a:t>Remediated Units</a:t>
+            </a:r>
+          </a:p>
+          <a:p>
+            <a:pPr>
+              <a:defRPr sz="900">
+                <a:solidFill>
+                  <a:srgbClr val="64748B"/>
+                </a:solidFill>
+                <a:latin typeface="Segoe UI"/>
+              </a:defRPr>
+            </a:pPr>
+            <a:r>
+              <a:t>ยอดผ่านเกณฑ์ตรงกัน 100%</a:t>
+            </a:r>
+          </a:p>
+        </p:txBody>
+      </p:sp>
+      <p:sp>
+        <p:nvSpPr>
+          <p:cNvPr id="10" name="Rounded Rectangle 9"/>
+          <p:cNvSpPr/>
+          <p:nvPr/>
+        </p:nvSpPr>
+        <p:spPr>
+          <a:xfrm>
+            <a:off x="8046720" y="1508760"/>
+            <a:ext cx="3383280" cy="1371600"/>
+          </a:xfrm>
+          <a:prstGeom prst="roundRect">
+            <a:avLst/>
+          </a:prstGeom>
+          <a:solidFill>
+            <a:srgbClr val="FFFFFF"/>
+          </a:solidFill>
+          <a:ln w="12700">
+            <a:solidFill>
+              <a:srgbClr val="E2E8F0"/>
+            </a:solidFill>
+          </a:ln>
+        </p:spPr>
+        <p:style>
+          <a:lnRef idx="1">
+            <a:schemeClr val="accent1"/>
+          </a:lnRef>
+          <a:fillRef idx="3">
+            <a:schemeClr val="accent1"/>
+          </a:fillRef>
+          <a:effectRef idx="2">
+            <a:schemeClr val="accent1"/>
+          </a:effectRef>
+          <a:fontRef idx="minor">
+            <a:schemeClr val="lt1"/>
+          </a:fontRef>
+        </p:style>
+        <p:txBody>
+          <a:bodyPr rtlCol="0" anchor="ctr"/>
+          <a:lstStyle/>
+          <a:p>
+            <a:pPr algn="ctr"/>
+          </a:p>
+        </p:txBody>
+      </p:sp>
+      <p:sp>
+        <p:nvSpPr>
+          <p:cNvPr id="11" name="Rectangle 10"/>
+          <p:cNvSpPr/>
+          <p:nvPr/>
+        </p:nvSpPr>
+        <p:spPr>
+          <a:xfrm>
+            <a:off x="8046720" y="1508760"/>
+            <a:ext cx="3383280" cy="73152"/>
+          </a:xfrm>
+          <a:prstGeom prst="rect">
+            <a:avLst/>
+          </a:prstGeom>
+          <a:solidFill>
+            <a:srgbClr val="10B981"/>
+          </a:solidFill>
+          <a:ln>
+            <a:noFill/>
+          </a:ln>
+        </p:spPr>
+        <p:style>
+          <a:lnRef idx="1">
+            <a:schemeClr val="accent1"/>
+          </a:lnRef>
+          <a:fillRef idx="3">
+            <a:schemeClr val="accent1"/>
+          </a:fillRef>
+          <a:effectRef idx="2">
+            <a:schemeClr val="accent1"/>
+          </a:effectRef>
+          <a:fontRef idx="minor">
+            <a:schemeClr val="lt1"/>
+          </a:fontRef>
+        </p:style>
+        <p:txBody>
+          <a:bodyPr rtlCol="0" anchor="ctr"/>
+          <a:lstStyle/>
+          <a:p>
+            <a:pPr algn="ctr"/>
+          </a:p>
+        </p:txBody>
+      </p:sp>
+      <p:sp>
+        <p:nvSpPr>
+          <p:cNvPr id="12" name="TextBox 11"/>
+          <p:cNvSpPr txBox="1"/>
+          <p:nvPr/>
+        </p:nvSpPr>
+        <p:spPr>
+          <a:xfrm>
+            <a:off x="8229600" y="1673352"/>
+            <a:ext cx="3017520" cy="1115568"/>
+          </a:xfrm>
+          <a:prstGeom prst="rect">
+            <a:avLst/>
+          </a:prstGeom>
+          <a:noFill/>
+        </p:spPr>
+        <p:txBody>
+          <a:bodyPr wrap="square" lIns="0" tIns="0" rIns="0" bIns="0">
+            <a:spAutoFit/>
+          </a:bodyPr>
+          <a:lstStyle/>
+          <a:p>
+            <a:pPr>
+              <a:defRPr sz="2800" b="1">
+                <a:solidFill>
+                  <a:srgbClr val="10B981"/>
+                </a:solidFill>
+                <a:latin typeface="Segoe UI"/>
+              </a:defRPr>
+            </a:pPr>
+            <a:r>
+              <a:t>0 Variance</a:t>
+            </a:r>
+          </a:p>
+          <a:p>
+            <a:pPr>
+              <a:defRPr sz="1000" b="1">
+                <a:solidFill>
+                  <a:srgbClr val="0F172A"/>
+                </a:solidFill>
+                <a:latin typeface="Segoe UI"/>
+              </a:defRPr>
+            </a:pPr>
+            <a:r>
+              <a:t>Audit Discrepancy</a:t>
+            </a:r>
+          </a:p>
+          <a:p>
+            <a:pPr>
+              <a:defRPr sz="900">
+                <a:solidFill>
+                  <a:srgbClr val="64748B"/>
+                </a:solidFill>
+                <a:latin typeface="Segoe UI"/>
+              </a:defRPr>
+            </a:pPr>
+            <a:r>
+              <a:t>ตรวจสอบรายเซลล์ถูกต้องสมบูรณ์</a:t>
+            </a:r>
+          </a:p>
+        </p:txBody>
+      </p:sp>
+      <p:graphicFrame>
+        <p:nvGraphicFramePr>
+          <p:cNvPr id="13" name="Table 12"/>
+          <p:cNvGraphicFramePr>
+            <a:graphicFrameLocks noGrp="1"/>
+          </p:cNvGraphicFramePr>
+          <p:nvPr/>
+        </p:nvGraphicFramePr>
+        <p:xfrm>
+          <a:off x="731520" y="3063240"/>
+          <a:ext cx="10698480" cy="3291840"/>
+        </p:xfrm>
+        <a:graphic>
+          <a:graphicData uri="http://schemas.openxmlformats.org/drawingml/2006/table">
+            <a:tbl>
+              <a:tblPr firstRow="1" bandRow="1">
+                <a:tableStyleId>{5C22544A-7EE6-4342-B048-85BDC9FD1C3A}</a:tableStyleId>
+              </a:tblPr>
+              <a:tblGrid>
+                <a:gridCol w="3383280"/>
+                <a:gridCol w="1828800"/>
+                <a:gridCol w="1828800"/>
+                <a:gridCol w="1828800"/>
+                <a:gridCol w="1828800"/>
+              </a:tblGrid>
+              <a:tr h="411480">
+                <a:tc>
+                  <a:txBody>
+                    <a:bodyPr/>
+                    <a:lstStyle/>
+                    <a:p>
+                      <a:pPr algn="l">
+                        <a:defRPr b="1" sz="1000">
+                          <a:solidFill>
+                            <a:srgbClr val="FFFFFF"/>
+                          </a:solidFill>
+                          <a:latin typeface="Segoe UI"/>
+                        </a:defRPr>
+                      </a:pPr>
+                      <a:r>
+                        <a:t>มิติการตรวจสอบ (Audit Dimension)</a:t>
+                      </a:r>
+                    </a:p>
+                  </a:txBody>
+                  <a:tcPr>
+                    <a:solidFill>
+                      <a:srgbClr val="0F172A"/>
+                    </a:solidFill>
+                  </a:tcPr>
+                </a:tc>
+                <a:tc>
+                  <a:txBody>
+                    <a:bodyPr/>
+                    <a:lstStyle/>
+                    <a:p>
+                      <a:pPr algn="ctr">
+                        <a:defRPr b="1" sz="1000">
+                          <a:solidFill>
+                            <a:srgbClr val="FFFFFF"/>
+                          </a:solidFill>
+                          <a:latin typeface="Segoe UI"/>
+                        </a:defRPr>
+                      </a:pPr>
+                      <a:r>
+                        <a:t>1. Excel OneDrive Q4</a:t>
+                      </a:r>
+                    </a:p>
+                  </a:txBody>
+                  <a:tcPr>
+                    <a:solidFill>
+                      <a:srgbClr val="0F172A"/>
+                    </a:solidFill>
+                  </a:tcPr>
+                </a:tc>
+                <a:tc>
+                  <a:txBody>
+                    <a:bodyPr/>
+                    <a:lstStyle/>
+                    <a:p>
+                      <a:pPr algn="ctr">
+                        <a:defRPr b="1" sz="1000">
+                          <a:solidFill>
+                            <a:srgbClr val="FFFFFF"/>
+                          </a:solidFill>
+                          <a:latin typeface="Segoe UI"/>
+                        </a:defRPr>
+                      </a:pPr>
+                      <a:r>
+                        <a:t>2. ส่วนบน Dashboard</a:t>
+                      </a:r>
+                    </a:p>
+                  </a:txBody>
+                  <a:tcPr>
+                    <a:solidFill>
+                      <a:srgbClr val="0F172A"/>
+                    </a:solidFill>
+                  </a:tcPr>
+                </a:tc>
+                <a:tc>
+                  <a:txBody>
+                    <a:bodyPr/>
+                    <a:lstStyle/>
+                    <a:p>
+                      <a:pPr algn="ctr">
+                        <a:defRPr b="1" sz="1000">
+                          <a:solidFill>
+                            <a:srgbClr val="FFFFFF"/>
+                          </a:solidFill>
+                          <a:latin typeface="Segoe UI"/>
+                        </a:defRPr>
+                      </a:pPr>
+                      <a:r>
+                        <a:t>3. BU Matrix Table</a:t>
+                      </a:r>
+                    </a:p>
+                  </a:txBody>
+                  <a:tcPr>
+                    <a:solidFill>
+                      <a:srgbClr val="0F172A"/>
+                    </a:solidFill>
+                  </a:tcPr>
+                </a:tc>
+                <a:tc>
+                  <a:txBody>
+                    <a:bodyPr/>
+                    <a:lstStyle/>
+                    <a:p>
+                      <a:pPr algn="ctr">
+                        <a:defRPr b="1" sz="1000">
+                          <a:solidFill>
+                            <a:srgbClr val="FFFFFF"/>
+                          </a:solidFill>
+                          <a:latin typeface="Segoe UI"/>
+                        </a:defRPr>
+                      </a:pPr>
+                      <a:r>
+                        <a:t>ผลการตรวจสอบ</a:t>
+                      </a:r>
+                    </a:p>
+                  </a:txBody>
+                  <a:tcPr>
+                    <a:solidFill>
+                      <a:srgbClr val="0F172A"/>
+                    </a:solidFill>
+                  </a:tcPr>
+                </a:tc>
+              </a:tr>
+              <a:tr h="411480">
+                <a:tc>
+                  <a:txBody>
+                    <a:bodyPr/>
+                    <a:lstStyle/>
+                    <a:p>
+                      <a:pPr algn="l">
+                        <a:defRPr sz="950">
+                          <a:solidFill>
+                            <a:srgbClr val="0F172A"/>
+                          </a:solidFill>
+                          <a:latin typeface="Segoe UI"/>
+                        </a:defRPr>
+                      </a:pPr>
+                      <a:r>
+                        <a:t>Grand Total Scope (เป้าหมายทั้งหมด)</a:t>
+                      </a:r>
+                    </a:p>
+                  </a:txBody>
+                  <a:tcPr>
+                    <a:solidFill>
+                      <a:srgbClr val="FFFFFF"/>
+                    </a:solidFill>
+                  </a:tcPr>
+                </a:tc>
+                <a:tc>
+                  <a:txBody>
+                    <a:bodyPr/>
+                    <a:lstStyle/>
+                    <a:p>
+                      <a:pPr algn="ctr">
+                        <a:defRPr sz="950">
+                          <a:solidFill>
+                            <a:srgbClr val="0F172A"/>
+                          </a:solidFill>
+                          <a:latin typeface="Segoe UI"/>
+                        </a:defRPr>
+                      </a:pPr>
+                      <a:r>
+                        <a:t>5,092 เครื่อง</a:t>
+                      </a:r>
+                    </a:p>
+                  </a:txBody>
+                  <a:tcPr>
+                    <a:solidFill>
+                      <a:srgbClr val="FFFFFF"/>
+                    </a:solidFill>
+                  </a:tcPr>
+                </a:tc>
+                <a:tc>
+                  <a:txBody>
+                    <a:bodyPr/>
+                    <a:lstStyle/>
+                    <a:p>
+                      <a:pPr algn="ctr">
+                        <a:defRPr sz="950">
+                          <a:solidFill>
+                            <a:srgbClr val="0F172A"/>
+                          </a:solidFill>
+                          <a:latin typeface="Segoe UI"/>
+                        </a:defRPr>
+                      </a:pPr>
+                      <a:r>
+                        <a:t>5,092 เครื่อง</a:t>
+                      </a:r>
+                    </a:p>
+                  </a:txBody>
+                  <a:tcPr>
+                    <a:solidFill>
+                      <a:srgbClr val="FFFFFF"/>
+                    </a:solidFill>
+                  </a:tcPr>
+                </a:tc>
+                <a:tc>
+                  <a:txBody>
+                    <a:bodyPr/>
+                    <a:lstStyle/>
+                    <a:p>
+                      <a:pPr algn="ctr">
+                        <a:defRPr sz="950">
+                          <a:solidFill>
+                            <a:srgbClr val="0F172A"/>
+                          </a:solidFill>
+                          <a:latin typeface="Segoe UI"/>
+                        </a:defRPr>
+                      </a:pPr>
+                      <a:r>
+                        <a:t>5,092 เครื่อง</a:t>
+                      </a:r>
+                    </a:p>
+                  </a:txBody>
+                  <a:tcPr>
+                    <a:solidFill>
+                      <a:srgbClr val="FFFFFF"/>
+                    </a:solidFill>
+                  </a:tcPr>
+                </a:tc>
+                <a:tc>
+                  <a:txBody>
+                    <a:bodyPr/>
+                    <a:lstStyle/>
+                    <a:p>
+                      <a:pPr algn="ctr">
+                        <a:defRPr sz="950" b="1">
+                          <a:solidFill>
+                            <a:srgbClr val="10B981"/>
+                          </a:solidFill>
+                          <a:latin typeface="Segoe UI"/>
+                        </a:defRPr>
+                      </a:pPr>
+                      <a:r>
+                        <a:t>✅ MATCH 100%</a:t>
+                      </a:r>
+                    </a:p>
+                  </a:txBody>
+                  <a:tcPr>
+                    <a:solidFill>
+                      <a:srgbClr val="FFFFFF"/>
+                    </a:solidFill>
+                  </a:tcPr>
+                </a:tc>
+              </a:tr>
+              <a:tr h="411480">
+                <a:tc>
+                  <a:txBody>
+                    <a:bodyPr/>
+                    <a:lstStyle/>
+                    <a:p>
+                      <a:pPr algn="l">
+                        <a:defRPr sz="950">
+                          <a:solidFill>
+                            <a:srgbClr val="0F172A"/>
+                          </a:solidFill>
+                          <a:latin typeface="Segoe UI"/>
+                        </a:defRPr>
+                      </a:pPr>
+                      <a:r>
+                        <a:t>Passed Remediated (ผ่านเกณฑ์แล้ว)</a:t>
+                      </a:r>
+                    </a:p>
+                  </a:txBody>
+                  <a:tcPr>
+                    <a:solidFill>
+                      <a:srgbClr val="F8FAFC"/>
+                    </a:solidFill>
+                  </a:tcPr>
+                </a:tc>
+                <a:tc>
+                  <a:txBody>
+                    <a:bodyPr/>
+                    <a:lstStyle/>
+                    <a:p>
+                      <a:pPr algn="ctr">
+                        <a:defRPr sz="950">
+                          <a:solidFill>
+                            <a:srgbClr val="0F172A"/>
+                          </a:solidFill>
+                          <a:latin typeface="Segoe UI"/>
+                        </a:defRPr>
+                      </a:pPr>
+                      <a:r>
+                        <a:t>361 เครื่อง</a:t>
+                      </a:r>
+                    </a:p>
+                  </a:txBody>
+                  <a:tcPr>
+                    <a:solidFill>
+                      <a:srgbClr val="F8FAFC"/>
+                    </a:solidFill>
+                  </a:tcPr>
+                </a:tc>
+                <a:tc>
+                  <a:txBody>
+                    <a:bodyPr/>
+                    <a:lstStyle/>
+                    <a:p>
+                      <a:pPr algn="ctr">
+                        <a:defRPr sz="950">
+                          <a:solidFill>
+                            <a:srgbClr val="0F172A"/>
+                          </a:solidFill>
+                          <a:latin typeface="Segoe UI"/>
+                        </a:defRPr>
+                      </a:pPr>
+                      <a:r>
+                        <a:t>361 เครื่อง</a:t>
+                      </a:r>
+                    </a:p>
+                  </a:txBody>
+                  <a:tcPr>
+                    <a:solidFill>
+                      <a:srgbClr val="F8FAFC"/>
+                    </a:solidFill>
+                  </a:tcPr>
+                </a:tc>
+                <a:tc>
+                  <a:txBody>
+                    <a:bodyPr/>
+                    <a:lstStyle/>
+                    <a:p>
+                      <a:pPr algn="ctr">
+                        <a:defRPr sz="950">
+                          <a:solidFill>
+                            <a:srgbClr val="0F172A"/>
+                          </a:solidFill>
+                          <a:latin typeface="Segoe UI"/>
+                        </a:defRPr>
+                      </a:pPr>
+                      <a:r>
+                        <a:t>361 เครื่อง</a:t>
+                      </a:r>
+                    </a:p>
+                  </a:txBody>
+                  <a:tcPr>
+                    <a:solidFill>
+                      <a:srgbClr val="F8FAFC"/>
+                    </a:solidFill>
+                  </a:tcPr>
+                </a:tc>
+                <a:tc>
+                  <a:txBody>
+                    <a:bodyPr/>
+                    <a:lstStyle/>
+                    <a:p>
+                      <a:pPr algn="ctr">
+                        <a:defRPr sz="950" b="1">
+                          <a:solidFill>
+                            <a:srgbClr val="10B981"/>
+                          </a:solidFill>
+                          <a:latin typeface="Segoe UI"/>
+                        </a:defRPr>
+                      </a:pPr>
+                      <a:r>
+                        <a:t>✅ MATCH 100%</a:t>
+                      </a:r>
+                    </a:p>
+                  </a:txBody>
+                  <a:tcPr>
+                    <a:solidFill>
+                      <a:srgbClr val="F8FAFC"/>
+                    </a:solidFill>
+                  </a:tcPr>
+                </a:tc>
+              </a:tr>
+              <a:tr h="411480">
+                <a:tc>
+                  <a:txBody>
+                    <a:bodyPr/>
+                    <a:lstStyle/>
+                    <a:p>
+                      <a:pPr algn="l">
+                        <a:defRPr sz="950">
+                          <a:solidFill>
+                            <a:srgbClr val="0F172A"/>
+                          </a:solidFill>
+                          <a:latin typeface="Segoe UI"/>
+                        </a:defRPr>
+                      </a:pPr>
+                      <a:r>
+                        <a:t>Pending Remediated (รอดำเนินการ)</a:t>
+                      </a:r>
+                    </a:p>
+                  </a:txBody>
+                  <a:tcPr>
+                    <a:solidFill>
+                      <a:srgbClr val="FFFFFF"/>
+                    </a:solidFill>
+                  </a:tcPr>
+                </a:tc>
+                <a:tc>
+                  <a:txBody>
+                    <a:bodyPr/>
+                    <a:lstStyle/>
+                    <a:p>
+                      <a:pPr algn="ctr">
+                        <a:defRPr sz="950">
+                          <a:solidFill>
+                            <a:srgbClr val="0F172A"/>
+                          </a:solidFill>
+                          <a:latin typeface="Segoe UI"/>
+                        </a:defRPr>
+                      </a:pPr>
+                      <a:r>
+                        <a:t>4,731 เครื่อง</a:t>
+                      </a:r>
+                    </a:p>
+                  </a:txBody>
+                  <a:tcPr>
+                    <a:solidFill>
+                      <a:srgbClr val="FFFFFF"/>
+                    </a:solidFill>
+                  </a:tcPr>
+                </a:tc>
+                <a:tc>
+                  <a:txBody>
+                    <a:bodyPr/>
+                    <a:lstStyle/>
+                    <a:p>
+                      <a:pPr algn="ctr">
+                        <a:defRPr sz="950">
+                          <a:solidFill>
+                            <a:srgbClr val="0F172A"/>
+                          </a:solidFill>
+                          <a:latin typeface="Segoe UI"/>
+                        </a:defRPr>
+                      </a:pPr>
+                      <a:r>
+                        <a:t>4,731 เครื่อง</a:t>
+                      </a:r>
+                    </a:p>
+                  </a:txBody>
+                  <a:tcPr>
+                    <a:solidFill>
+                      <a:srgbClr val="FFFFFF"/>
+                    </a:solidFill>
+                  </a:tcPr>
+                </a:tc>
+                <a:tc>
+                  <a:txBody>
+                    <a:bodyPr/>
+                    <a:lstStyle/>
+                    <a:p>
+                      <a:pPr algn="ctr">
+                        <a:defRPr sz="950">
+                          <a:solidFill>
+                            <a:srgbClr val="0F172A"/>
+                          </a:solidFill>
+                          <a:latin typeface="Segoe UI"/>
+                        </a:defRPr>
+                      </a:pPr>
+                      <a:r>
+                        <a:t>4,731 เครื่อง</a:t>
+                      </a:r>
+                    </a:p>
+                  </a:txBody>
+                  <a:tcPr>
+                    <a:solidFill>
+                      <a:srgbClr val="FFFFFF"/>
+                    </a:solidFill>
+                  </a:tcPr>
+                </a:tc>
+                <a:tc>
+                  <a:txBody>
+                    <a:bodyPr/>
+                    <a:lstStyle/>
+                    <a:p>
+                      <a:pPr algn="ctr">
+                        <a:defRPr sz="950" b="1">
+                          <a:solidFill>
+                            <a:srgbClr val="10B981"/>
+                          </a:solidFill>
+                          <a:latin typeface="Segoe UI"/>
+                        </a:defRPr>
+                      </a:pPr>
+                      <a:r>
+                        <a:t>✅ MATCH 100%</a:t>
+                      </a:r>
+                    </a:p>
+                  </a:txBody>
+                  <a:tcPr>
+                    <a:solidFill>
+                      <a:srgbClr val="FFFFFF"/>
+                    </a:solidFill>
+                  </a:tcPr>
+                </a:tc>
+              </a:tr>
+              <a:tr h="411480">
+                <a:tc>
+                  <a:txBody>
+                    <a:bodyPr/>
+                    <a:lstStyle/>
+                    <a:p>
+                      <a:pPr algn="l">
+                        <a:defRPr sz="950">
+                          <a:solidFill>
+                            <a:srgbClr val="0F172A"/>
+                          </a:solidFill>
+                          <a:latin typeface="Segoe UI"/>
+                        </a:defRPr>
+                      </a:pPr>
+                      <a:r>
+                        <a:t>9 Topics Evaluation (ผลประเมิน 9 หัวข้อ)</a:t>
+                      </a:r>
+                    </a:p>
+                  </a:txBody>
+                  <a:tcPr>
+                    <a:solidFill>
+                      <a:srgbClr val="F8FAFC"/>
+                    </a:solidFill>
+                  </a:tcPr>
+                </a:tc>
+                <a:tc>
+                  <a:txBody>
+                    <a:bodyPr/>
+                    <a:lstStyle/>
+                    <a:p>
+                      <a:pPr algn="ctr">
+                        <a:defRPr sz="950">
+                          <a:solidFill>
+                            <a:srgbClr val="0F172A"/>
+                          </a:solidFill>
+                          <a:latin typeface="Segoe UI"/>
+                        </a:defRPr>
+                      </a:pPr>
+                      <a:r>
+                        <a:t>ครบ 9 หัวข้อ</a:t>
+                      </a:r>
+                    </a:p>
+                  </a:txBody>
+                  <a:tcPr>
+                    <a:solidFill>
+                      <a:srgbClr val="F8FAFC"/>
+                    </a:solidFill>
+                  </a:tcPr>
+                </a:tc>
+                <a:tc>
+                  <a:txBody>
+                    <a:bodyPr/>
+                    <a:lstStyle/>
+                    <a:p>
+                      <a:pPr algn="ctr">
+                        <a:defRPr sz="950">
+                          <a:solidFill>
+                            <a:srgbClr val="0F172A"/>
+                          </a:solidFill>
+                          <a:latin typeface="Segoe UI"/>
+                        </a:defRPr>
+                      </a:pPr>
+                      <a:r>
+                        <a:t>ครบ 9 หัวข้อ</a:t>
+                      </a:r>
+                    </a:p>
+                  </a:txBody>
+                  <a:tcPr>
+                    <a:solidFill>
+                      <a:srgbClr val="F8FAFC"/>
+                    </a:solidFill>
+                  </a:tcPr>
+                </a:tc>
+                <a:tc>
+                  <a:txBody>
+                    <a:bodyPr/>
+                    <a:lstStyle/>
+                    <a:p>
+                      <a:pPr algn="ctr">
+                        <a:defRPr sz="950">
+                          <a:solidFill>
+                            <a:srgbClr val="0F172A"/>
+                          </a:solidFill>
+                          <a:latin typeface="Segoe UI"/>
+                        </a:defRPr>
+                      </a:pPr>
+                      <a:r>
+                        <a:t>ครบ 9 หัวข้อ</a:t>
+                      </a:r>
+                    </a:p>
+                  </a:txBody>
+                  <a:tcPr>
+                    <a:solidFill>
+                      <a:srgbClr val="F8FAFC"/>
+                    </a:solidFill>
+                  </a:tcPr>
+                </a:tc>
+                <a:tc>
+                  <a:txBody>
+                    <a:bodyPr/>
+                    <a:lstStyle/>
+                    <a:p>
+                      <a:pPr algn="ctr">
+                        <a:defRPr sz="950" b="1">
+                          <a:solidFill>
+                            <a:srgbClr val="10B981"/>
+                          </a:solidFill>
+                          <a:latin typeface="Segoe UI"/>
+                        </a:defRPr>
+                      </a:pPr>
+                      <a:r>
+                        <a:t>✅ MATCH 100%</a:t>
+                      </a:r>
+                    </a:p>
+                  </a:txBody>
+                  <a:tcPr>
+                    <a:solidFill>
+                      <a:srgbClr val="F8FAFC"/>
+                    </a:solidFill>
+                  </a:tcPr>
+                </a:tc>
+              </a:tr>
+              <a:tr h="411480">
+                <a:tc>
+                  <a:txBody>
+                    <a:bodyPr/>
+                    <a:lstStyle/>
+                    <a:p>
+                      <a:pPr algn="l">
+                        <a:defRPr sz="950">
+                          <a:solidFill>
+                            <a:srgbClr val="0F172A"/>
+                          </a:solidFill>
+                          <a:latin typeface="Segoe UI"/>
+                        </a:defRPr>
+                      </a:pPr>
+                      <a:r>
+                        <a:t>Support Teams Fleet (DC / HO / Branch)</a:t>
+                      </a:r>
+                    </a:p>
+                  </a:txBody>
+                  <a:tcPr>
+                    <a:solidFill>
+                      <a:srgbClr val="FFFFFF"/>
+                    </a:solidFill>
+                  </a:tcPr>
+                </a:tc>
+                <a:tc>
+                  <a:txBody>
+                    <a:bodyPr/>
+                    <a:lstStyle/>
+                    <a:p>
+                      <a:pPr algn="ctr">
+                        <a:defRPr sz="950">
+                          <a:solidFill>
+                            <a:srgbClr val="0F172A"/>
+                          </a:solidFill>
+                          <a:latin typeface="Segoe UI"/>
+                        </a:defRPr>
+                      </a:pPr>
+                      <a:r>
+                        <a:t>533 / 609 / 3,855</a:t>
+                      </a:r>
+                    </a:p>
+                  </a:txBody>
+                  <a:tcPr>
+                    <a:solidFill>
+                      <a:srgbClr val="FFFFFF"/>
+                    </a:solidFill>
+                  </a:tcPr>
+                </a:tc>
+                <a:tc>
+                  <a:txBody>
+                    <a:bodyPr/>
+                    <a:lstStyle/>
+                    <a:p>
+                      <a:pPr algn="ctr">
+                        <a:defRPr sz="950">
+                          <a:solidFill>
+                            <a:srgbClr val="0F172A"/>
+                          </a:solidFill>
+                          <a:latin typeface="Segoe UI"/>
+                        </a:defRPr>
+                      </a:pPr>
+                      <a:r>
+                        <a:t>533 / 609 / 3,855</a:t>
+                      </a:r>
+                    </a:p>
+                  </a:txBody>
+                  <a:tcPr>
+                    <a:solidFill>
+                      <a:srgbClr val="FFFFFF"/>
+                    </a:solidFill>
+                  </a:tcPr>
+                </a:tc>
+                <a:tc>
+                  <a:txBody>
+                    <a:bodyPr/>
+                    <a:lstStyle/>
+                    <a:p>
+                      <a:pPr algn="ctr">
+                        <a:defRPr sz="950">
+                          <a:solidFill>
+                            <a:srgbClr val="0F172A"/>
+                          </a:solidFill>
+                          <a:latin typeface="Segoe UI"/>
+                        </a:defRPr>
+                      </a:pPr>
+                      <a:r>
+                        <a:t>533 / 609 / 3,855</a:t>
+                      </a:r>
+                    </a:p>
+                  </a:txBody>
+                  <a:tcPr>
+                    <a:solidFill>
+                      <a:srgbClr val="FFFFFF"/>
+                    </a:solidFill>
+                  </a:tcPr>
+                </a:tc>
+                <a:tc>
+                  <a:txBody>
+                    <a:bodyPr/>
+                    <a:lstStyle/>
+                    <a:p>
+                      <a:pPr algn="ctr">
+                        <a:defRPr sz="950" b="1">
+                          <a:solidFill>
+                            <a:srgbClr val="10B981"/>
+                          </a:solidFill>
+                          <a:latin typeface="Segoe UI"/>
+                        </a:defRPr>
+                      </a:pPr>
+                      <a:r>
+                        <a:t>✅ MATCH 100%</a:t>
+                      </a:r>
+                    </a:p>
+                  </a:txBody>
+                  <a:tcPr>
+                    <a:solidFill>
+                      <a:srgbClr val="FFFFFF"/>
+                    </a:solidFill>
+                  </a:tcPr>
+                </a:tc>
+              </a:tr>
+              <a:tr h="411480">
+                <a:tc>
+                  <a:txBody>
+                    <a:bodyPr/>
+                    <a:lstStyle/>
+                    <a:p>
+                      <a:pPr algn="l">
+                        <a:defRPr sz="950">
+                          <a:solidFill>
+                            <a:srgbClr val="0F172A"/>
+                          </a:solidFill>
+                          <a:latin typeface="Segoe UI"/>
+                        </a:defRPr>
+                      </a:pPr>
+                      <a:r>
+                        <a:t>Unassigned / RIS No Service</a:t>
+                      </a:r>
+                    </a:p>
+                  </a:txBody>
+                  <a:tcPr>
+                    <a:solidFill>
+                      <a:srgbClr val="F8FAFC"/>
+                    </a:solidFill>
+                  </a:tcPr>
+                </a:tc>
+                <a:tc>
+                  <a:txBody>
+                    <a:bodyPr/>
+                    <a:lstStyle/>
+                    <a:p>
+                      <a:pPr algn="ctr">
+                        <a:defRPr sz="950">
+                          <a:solidFill>
+                            <a:srgbClr val="0F172A"/>
+                          </a:solidFill>
+                          <a:latin typeface="Segoe UI"/>
+                        </a:defRPr>
+                      </a:pPr>
+                      <a:r>
+                        <a:t>95 เครื่อง</a:t>
+                      </a:r>
+                    </a:p>
+                  </a:txBody>
+                  <a:tcPr>
+                    <a:solidFill>
+                      <a:srgbClr val="F8FAFC"/>
+                    </a:solidFill>
+                  </a:tcPr>
+                </a:tc>
+                <a:tc>
+                  <a:txBody>
+                    <a:bodyPr/>
+                    <a:lstStyle/>
+                    <a:p>
+                      <a:pPr algn="ctr">
+                        <a:defRPr sz="950">
+                          <a:solidFill>
+                            <a:srgbClr val="0F172A"/>
+                          </a:solidFill>
+                          <a:latin typeface="Segoe UI"/>
+                        </a:defRPr>
+                      </a:pPr>
+                      <a:r>
+                        <a:t>95 เครื่อง</a:t>
+                      </a:r>
+                    </a:p>
+                  </a:txBody>
+                  <a:tcPr>
+                    <a:solidFill>
+                      <a:srgbClr val="F8FAFC"/>
+                    </a:solidFill>
+                  </a:tcPr>
+                </a:tc>
+                <a:tc>
+                  <a:txBody>
+                    <a:bodyPr/>
+                    <a:lstStyle/>
+                    <a:p>
+                      <a:pPr algn="ctr">
+                        <a:defRPr sz="950">
+                          <a:solidFill>
+                            <a:srgbClr val="0F172A"/>
+                          </a:solidFill>
+                          <a:latin typeface="Segoe UI"/>
+                        </a:defRPr>
+                      </a:pPr>
+                      <a:r>
+                        <a:t>95 เครื่อง</a:t>
+                      </a:r>
+                    </a:p>
+                  </a:txBody>
+                  <a:tcPr>
+                    <a:solidFill>
+                      <a:srgbClr val="F8FAFC"/>
+                    </a:solidFill>
+                  </a:tcPr>
+                </a:tc>
+                <a:tc>
+                  <a:txBody>
+                    <a:bodyPr/>
+                    <a:lstStyle/>
+                    <a:p>
+                      <a:pPr algn="ctr">
+                        <a:defRPr sz="950" b="1">
+                          <a:solidFill>
+                            <a:srgbClr val="10B981"/>
+                          </a:solidFill>
+                          <a:latin typeface="Segoe UI"/>
+                        </a:defRPr>
+                      </a:pPr>
+                      <a:r>
+                        <a:t>✅ MATCH 100%</a:t>
+                      </a:r>
+                    </a:p>
+                  </a:txBody>
+                  <a:tcPr>
+                    <a:solidFill>
+                      <a:srgbClr val="F8FAFC"/>
+                    </a:solidFill>
+                  </a:tcPr>
+                </a:tc>
+              </a:tr>
+              <a:tr h="411480">
+                <a:tc>
+                  <a:txBody>
+                    <a:bodyPr/>
+                    <a:lstStyle/>
+                    <a:p>
+                      <a:pPr algn="l">
+                        <a:defRPr sz="950">
+                          <a:solidFill>
+                            <a:srgbClr val="0F172A"/>
+                          </a:solidFill>
+                          <a:latin typeface="Segoe UI"/>
+                        </a:defRPr>
+                      </a:pPr>
+                      <a:r>
+                        <a:t>BU Breakdown Alignment (ราย BU ทั้งระบบ)</a:t>
+                      </a:r>
+                    </a:p>
+                  </a:txBody>
+                  <a:tcPr>
+                    <a:solidFill>
+                      <a:srgbClr val="FFFFFF"/>
+                    </a:solidFill>
+                  </a:tcPr>
+                </a:tc>
+                <a:tc>
+                  <a:txBody>
+                    <a:bodyPr/>
+                    <a:lstStyle/>
+                    <a:p>
+                      <a:pPr algn="ctr">
+                        <a:defRPr sz="950">
+                          <a:solidFill>
+                            <a:srgbClr val="0F172A"/>
+                          </a:solidFill>
+                          <a:latin typeface="Segoe UI"/>
+                        </a:defRPr>
+                      </a:pPr>
+                      <a:r>
+                        <a:t>100% Verified</a:t>
+                      </a:r>
+                    </a:p>
+                  </a:txBody>
+                  <a:tcPr>
+                    <a:solidFill>
+                      <a:srgbClr val="FFFFFF"/>
+                    </a:solidFill>
+                  </a:tcPr>
+                </a:tc>
+                <a:tc>
+                  <a:txBody>
+                    <a:bodyPr/>
+                    <a:lstStyle/>
+                    <a:p>
+                      <a:pPr algn="ctr">
+                        <a:defRPr sz="950">
+                          <a:solidFill>
+                            <a:srgbClr val="0F172A"/>
+                          </a:solidFill>
+                          <a:latin typeface="Segoe UI"/>
+                        </a:defRPr>
+                      </a:pPr>
+                      <a:r>
+                        <a:t>100% Verified</a:t>
+                      </a:r>
+                    </a:p>
+                  </a:txBody>
+                  <a:tcPr>
+                    <a:solidFill>
+                      <a:srgbClr val="FFFFFF"/>
+                    </a:solidFill>
+                  </a:tcPr>
+                </a:tc>
+                <a:tc>
+                  <a:txBody>
+                    <a:bodyPr/>
+                    <a:lstStyle/>
+                    <a:p>
+                      <a:pPr algn="ctr">
+                        <a:defRPr sz="950">
+                          <a:solidFill>
+                            <a:srgbClr val="0F172A"/>
+                          </a:solidFill>
+                          <a:latin typeface="Segoe UI"/>
+                        </a:defRPr>
+                      </a:pPr>
+                      <a:r>
+                        <a:t>100% Verified</a:t>
+                      </a:r>
+                    </a:p>
+                  </a:txBody>
+                  <a:tcPr>
+                    <a:solidFill>
+                      <a:srgbClr val="FFFFFF"/>
+                    </a:solidFill>
+                  </a:tcPr>
+                </a:tc>
+                <a:tc>
+                  <a:txBody>
+                    <a:bodyPr/>
+                    <a:lstStyle/>
+                    <a:p>
+                      <a:pPr algn="ctr">
+                        <a:defRPr sz="950" b="1">
+                          <a:solidFill>
+                            <a:srgbClr val="10B981"/>
+                          </a:solidFill>
+                          <a:latin typeface="Segoe UI"/>
+                        </a:defRPr>
+                      </a:pPr>
+                      <a:r>
+                        <a:t>✅ MATCH 100%</a:t>
+                      </a:r>
+                    </a:p>
+                  </a:txBody>
+                  <a:tcPr>
+                    <a:solidFill>
+                      <a:srgbClr val="FFFFFF"/>
+                    </a:solidFill>
+                  </a:tcPr>
+                </a:tc>
+              </a:tr>
+            </a:tbl>
+          </a:graphicData>
+        </a:graphic>
+      </p:graphicFrame>
+    </p:spTree>
+  </p:cSld>
+  <p:clrMapOvr>
+    <a:masterClrMapping/>
+  </p:clrMapOvr>
+</p:sld>
+</file>
+
+<file path=ppt/slides/slide4.xml><?xml version="1.0" encoding="utf-8"?>
+<p:sld xmlns:a="http://schemas.openxmlformats.org/drawingml/2006/main" xmlns:p="http://schemas.openxmlformats.org/presentationml/2006/main" xmlns:r="http://schemas.openxmlformats.org/officeDocument/2006/relationships">
+  <p:cSld>
+    <p:spTree>
+      <p:nvGrpSpPr>
+        <p:cNvPr id="1" name=""/>
+        <p:cNvGrpSpPr/>
+        <p:nvPr/>
+      </p:nvGrpSpPr>
+      <p:grpSpPr/>
+      <p:sp>
+        <p:nvSpPr>
+          <p:cNvPr id="2" name="Rectangle 1"/>
+          <p:cNvSpPr/>
+          <p:nvPr/>
+        </p:nvSpPr>
+        <p:spPr>
+          <a:xfrm>
+            <a:off x="0" y="0"/>
+            <a:ext cx="12191695" cy="6858000"/>
+          </a:xfrm>
+          <a:prstGeom prst="rect">
+            <a:avLst/>
+          </a:prstGeom>
+          <a:solidFill>
+            <a:srgbClr val="F8FAFC"/>
+          </a:solidFill>
+          <a:ln>
+            <a:noFill/>
+          </a:ln>
+        </p:spPr>
+        <p:style>
+          <a:lnRef idx="1">
+            <a:schemeClr val="accent1"/>
+          </a:lnRef>
+          <a:fillRef idx="3">
+            <a:schemeClr val="accent1"/>
+          </a:fillRef>
+          <a:effectRef idx="2">
+            <a:schemeClr val="accent1"/>
+          </a:effectRef>
+          <a:fontRef idx="minor">
+            <a:schemeClr val="lt1"/>
+          </a:fontRef>
+        </p:style>
+        <p:txBody>
+          <a:bodyPr rtlCol="0" anchor="ctr"/>
+          <a:lstStyle/>
+          <a:p>
+            <a:pPr algn="ctr"/>
+          </a:p>
+        </p:txBody>
+      </p:sp>
+      <p:sp>
+        <p:nvSpPr>
+          <p:cNvPr id="3" name="TextBox 2"/>
+          <p:cNvSpPr txBox="1"/>
+          <p:nvPr/>
+        </p:nvSpPr>
+        <p:spPr>
+          <a:xfrm>
+            <a:off x="731520" y="365760"/>
+            <a:ext cx="10698480" cy="1005840"/>
+          </a:xfrm>
+          <a:prstGeom prst="rect">
+            <a:avLst/>
+          </a:prstGeom>
+          <a:noFill/>
+        </p:spPr>
+        <p:txBody>
+          <a:bodyPr wrap="square" lIns="0" tIns="0" rIns="0" bIns="0">
+            <a:spAutoFit/>
+          </a:bodyPr>
+          <a:lstStyle/>
+          <a:p>
+            <a:pPr>
+              <a:defRPr sz="1800" b="1">
+                <a:solidFill>
+                  <a:srgbClr val="0F172A"/>
+                </a:solidFill>
+                <a:latin typeface="Segoe UI"/>
+              </a:defRPr>
+            </a:pPr>
+            <a:r>
               <a:t>HEAVY-HITTERS DEEP DIVE  |  ภาระงานกว่า 93.4% กระจุกตัวอยู่ใน 4 หมวดหลัก โดย Windows 11 OS Update เป็นตัวแปรชี้ขาด</a:t>
             </a:r>
           </a:p>
@@ -5125,7 +6691,7 @@
 </p:sld>
 </file>
 
-<file path=ppt/slides/slide4.xml><?xml version="1.0" encoding="utf-8"?>
+<file path=ppt/slides/slide5.xml><?xml version="1.0" encoding="utf-8"?>
 <p:sld xmlns:a="http://schemas.openxmlformats.org/drawingml/2006/main" xmlns:p="http://schemas.openxmlformats.org/presentationml/2006/main" xmlns:r="http://schemas.openxmlformats.org/officeDocument/2006/relationships">
   <p:cSld>
     <p:spTree>
@@ -7401,7 +8967,7 @@
 </p:sld>
 </file>
 
-<file path=ppt/slides/slide5.xml><?xml version="1.0" encoding="utf-8"?>
+<file path=ppt/slides/slide6.xml><?xml version="1.0" encoding="utf-8"?>
 <p:sld xmlns:a="http://schemas.openxmlformats.org/drawingml/2006/main" xmlns:p="http://schemas.openxmlformats.org/presentationml/2006/main" xmlns:r="http://schemas.openxmlformats.org/officeDocument/2006/relationships">
   <p:cSld>
     <p:spTree>
@@ -8143,7 +9709,7 @@
 </p:sld>
 </file>
 
-<file path=ppt/slides/slide6.xml><?xml version="1.0" encoding="utf-8"?>
+<file path=ppt/slides/slide7.xml><?xml version="1.0" encoding="utf-8"?>
 <p:sld xmlns:a="http://schemas.openxmlformats.org/drawingml/2006/main" xmlns:p="http://schemas.openxmlformats.org/presentationml/2006/main" xmlns:r="http://schemas.openxmlformats.org/officeDocument/2006/relationships">
   <p:cSld>
     <p:spTree>
@@ -10282,7 +11848,7 @@
 </p:sld>
 </file>
 
-<file path=ppt/slides/slide7.xml><?xml version="1.0" encoding="utf-8"?>
+<file path=ppt/slides/slide8.xml><?xml version="1.0" encoding="utf-8"?>
 <p:sld xmlns:a="http://schemas.openxmlformats.org/drawingml/2006/main" xmlns:p="http://schemas.openxmlformats.org/presentationml/2006/main" xmlns:r="http://schemas.openxmlformats.org/officeDocument/2006/relationships">
   <p:cSld>
     <p:spTree>
@@ -10936,7 +12502,7 @@
 </p:sld>
 </file>
 
-<file path=ppt/slides/slide8.xml><?xml version="1.0" encoding="utf-8"?>
+<file path=ppt/slides/slide9.xml><?xml version="1.0" encoding="utf-8"?>
 <p:sld xmlns:a="http://schemas.openxmlformats.org/drawingml/2006/main" xmlns:p="http://schemas.openxmlformats.org/presentationml/2006/main" xmlns:r="http://schemas.openxmlformats.org/officeDocument/2006/relationships">
   <p:cSld>
     <p:spTree>

</xml_diff>